<commit_message>
Gas Town imported without speaker notes; timeline grouped by month, month written once on the left
</commit_message>
<xml_diff>
--- a/downloads/gastown-dev-with-ai-live-4.fr.pptx
+++ b/downloads/gastown-dev-with-ai-live-4.fr.pptx
@@ -517,8 +517,7 @@
           <a:p>
             <a:r>
               <a:rPr lang="en-US" dirty="0"/>
-              <a:t>Open on the model, not the tooling.
-This is not "AI coding faster"; it is how delivery gets organized when AI workers become part of the engineering system.</a:t>
+              <a:t/>
             </a:r>
             <a:endParaRPr lang="en-US" dirty="0"/>
           </a:p>
@@ -606,8 +605,7 @@
           <a:p>
             <a:r>
               <a:rPr lang="en-US" dirty="0"/>
-              <a:t>Use this slide to explain why dependency management matters.
-The important point: work becomes executable and inspectable.</a:t>
+              <a:t/>
             </a:r>
             <a:endParaRPr lang="en-US" dirty="0"/>
           </a:p>
@@ -695,8 +693,7 @@
           <a:p>
             <a:r>
               <a:rPr lang="en-US" dirty="0"/>
-              <a:t>Convoys should feel operational, not decorative.
-They are the shared handle for distributed delivery.</a:t>
+              <a:t/>
             </a:r>
             <a:endParaRPr lang="en-US" dirty="0"/>
           </a:p>
@@ -784,8 +781,7 @@
           <a:p>
             <a:r>
               <a:rPr lang="en-US" dirty="0"/>
-              <a:t>This is the "wow" moment, but keep it engineering-oriented.
-The claim is throughput through isolated execution.</a:t>
+              <a:t/>
             </a:r>
             <a:endParaRPr lang="en-US" dirty="0"/>
           </a:p>
@@ -873,8 +869,7 @@
           <a:p>
             <a:r>
               <a:rPr lang="en-US" dirty="0"/>
-              <a:t>Important for DiliTrust: supervision and control are not optional.
-This slide turns distributed execution into an operational system.</a:t>
+              <a:t/>
             </a:r>
             <a:endParaRPr lang="en-US" dirty="0"/>
           </a:p>
@@ -962,8 +957,7 @@
           <a:p>
             <a:r>
               <a:rPr lang="en-US" dirty="0"/>
-              <a:t>Switch to the browser and slow down.
-The audience must see that Agreement Hub changed because Gas Town delivered code.</a:t>
+              <a:t/>
             </a:r>
             <a:endParaRPr lang="en-US" dirty="0"/>
           </a:p>
@@ -1051,7 +1045,7 @@
           <a:p>
             <a:r>
               <a:rPr lang="en-US" dirty="0"/>
-              <a:t>This closes the conceptual loop with the exact five problems introduced earlier.</a:t>
+              <a:t/>
             </a:r>
             <a:endParaRPr lang="en-US" dirty="0"/>
           </a:p>
@@ -1139,8 +1133,7 @@
           <a:p>
             <a:r>
               <a:rPr lang="en-US" dirty="0"/>
-              <a:t>Final slide for Q&amp;A.
-Keep it quiet. Do not add new concepts.</a:t>
+              <a:t/>
             </a:r>
             <a:endParaRPr lang="en-US" dirty="0"/>
           </a:p>
@@ -1228,8 +1221,7 @@
           <a:p>
             <a:r>
               <a:rPr lang="en-US" dirty="0"/>
-              <a:t>Introduce the two presenters before moving into the AI practice evolution.
-Keep the slide simple: names, photos, and the angle each speaker brings to the story.</a:t>
+              <a:t/>
             </a:r>
             <a:endParaRPr lang="en-US" dirty="0"/>
           </a:p>
@@ -1317,8 +1309,7 @@
           <a:p>
             <a:r>
               <a:rPr lang="en-US" dirty="0"/>
-              <a:t>Inspired by Steve Yegge's "The 8 Stages of Dev Evolution To AI" framing.
-Use this as the bridge from personal AI practice to organizational orchestration.</a:t>
+              <a:t/>
             </a:r>
             <a:endParaRPr lang="en-US" dirty="0"/>
           </a:p>
@@ -1406,8 +1397,7 @@
           <a:p>
             <a:r>
               <a:rPr lang="en-US" dirty="0"/>
-              <a:t>Use this slide to ground the story in Steve Yegge's work before introducing the delivery problem.
-Keep it short: creator, book, why it matters for the model.</a:t>
+              <a:t/>
             </a:r>
             <a:endParaRPr lang="en-US" dirty="0"/>
           </a:p>
@@ -1495,8 +1485,7 @@
           <a:p>
             <a:r>
               <a:rPr lang="en-US" dirty="0"/>
-              <a:t>Use this slide as the atmosphere and vocabulary bridge before the problem slide.
-The story: Gas Town starts from vibe-coding chaos, then adds city-like operating roles so delivery can be supervised.</a:t>
+              <a:t/>
             </a:r>
             <a:endParaRPr lang="en-US" dirty="0"/>
           </a:p>
@@ -1584,11 +1573,7 @@
           <a:p>
             <a:r>
               <a:rPr lang="en-US" dirty="0"/>
-              <a:t>LIVE START:
-- Launch Gas Town.
-- Present Agreement Hub in the browser.
-- Ask the Mayor for the first implementation step.
-Contract: the deck explains, the terminal works, the app proves.</a:t>
+              <a:t/>
             </a:r>
             <a:endParaRPr lang="en-US" dirty="0"/>
           </a:p>
@@ -1676,8 +1661,7 @@
           <a:p>
             <a:r>
               <a:rPr lang="en-US" dirty="0"/>
-              <a:t>The audience should understand why Gas Town exists before we introduce roles.
-The bottleneck is not just model intelligence; it is coordination.</a:t>
+              <a:t/>
             </a:r>
             <a:endParaRPr lang="en-US" dirty="0"/>
           </a:p>
@@ -1765,8 +1749,7 @@
           <a:p>
             <a:r>
               <a:rPr lang="en-US" dirty="0"/>
-              <a:t>Use this slide to position Gas Town as an AI-native delivery organization.
-Avoid tool tour language.</a:t>
+              <a:t/>
             </a:r>
             <a:endParaRPr lang="en-US" dirty="0"/>
           </a:p>
@@ -1854,8 +1837,7 @@
           <a:p>
             <a:r>
               <a:rPr lang="en-US" dirty="0"/>
-              <a:t>This is a central slide. The key line is:
-The Mayor coordinates work. Polecats execute it.</a:t>
+              <a:t/>
             </a:r>
             <a:endParaRPr lang="en-US" dirty="0"/>
           </a:p>

</xml_diff>